<commit_message>
Polish presentation card spacing
</commit_message>
<xml_diff>
--- a/presentations/site-value-for-massage-therapist.pptx
+++ b/presentations/site-value-for-massage-therapist.pptx
@@ -2,22 +2,22 @@
 <file path=ppt/presentation.xml><?xml version="1.0" encoding="utf-8"?>
 <p:presentation xmlns:p="http://schemas.openxmlformats.org/presentationml/2006/main">
   <p:sldMasterIdLst>
-    <p:sldMasterId xmlns:r="http://schemas.openxmlformats.org/officeDocument/2006/relationships" id="2147483648" r:id="Ra70ad76d1e9740ae"/>
+    <p:sldMasterId xmlns:r="http://schemas.openxmlformats.org/officeDocument/2006/relationships" id="2147483648" r:id="R817cde3462d14a13"/>
   </p:sldMasterIdLst>
   <p:notesMasterIdLst>
-    <p:notesMasterId xmlns:r="http://schemas.openxmlformats.org/officeDocument/2006/relationships" r:id="R3412fd53af9949c0"/>
+    <p:notesMasterId xmlns:r="http://schemas.openxmlformats.org/officeDocument/2006/relationships" r:id="Rfaad9877df634459"/>
   </p:notesMasterIdLst>
   <p:sldIdLst>
-    <p:sldId xmlns:r="http://schemas.openxmlformats.org/officeDocument/2006/relationships" id="256" r:id="Rf2ade482749a4fbf"/>
-    <p:sldId xmlns:r="http://schemas.openxmlformats.org/officeDocument/2006/relationships" id="257" r:id="Rac94b0ecfd1844d7"/>
-    <p:sldId xmlns:r="http://schemas.openxmlformats.org/officeDocument/2006/relationships" id="258" r:id="R2c2f31bf2c5a46ed"/>
-    <p:sldId xmlns:r="http://schemas.openxmlformats.org/officeDocument/2006/relationships" id="259" r:id="R00ace7232fda4ed8"/>
-    <p:sldId xmlns:r="http://schemas.openxmlformats.org/officeDocument/2006/relationships" id="260" r:id="Rdf027a5019034f3a"/>
-    <p:sldId xmlns:r="http://schemas.openxmlformats.org/officeDocument/2006/relationships" id="261" r:id="R31d96c2ce7c6416d"/>
-    <p:sldId xmlns:r="http://schemas.openxmlformats.org/officeDocument/2006/relationships" id="262" r:id="R8ff918ea5a894be7"/>
-    <p:sldId xmlns:r="http://schemas.openxmlformats.org/officeDocument/2006/relationships" id="263" r:id="Red0155d95567406e"/>
-    <p:sldId xmlns:r="http://schemas.openxmlformats.org/officeDocument/2006/relationships" id="264" r:id="R6b340a2095804985"/>
-    <p:sldId xmlns:r="http://schemas.openxmlformats.org/officeDocument/2006/relationships" id="265" r:id="R96810e718cc64e8c"/>
+    <p:sldId xmlns:r="http://schemas.openxmlformats.org/officeDocument/2006/relationships" id="256" r:id="Rab4d6c3ba7ae43b0"/>
+    <p:sldId xmlns:r="http://schemas.openxmlformats.org/officeDocument/2006/relationships" id="257" r:id="R374c330692c34316"/>
+    <p:sldId xmlns:r="http://schemas.openxmlformats.org/officeDocument/2006/relationships" id="258" r:id="R83724daa1cde4cc9"/>
+    <p:sldId xmlns:r="http://schemas.openxmlformats.org/officeDocument/2006/relationships" id="259" r:id="R1315f94d6051499c"/>
+    <p:sldId xmlns:r="http://schemas.openxmlformats.org/officeDocument/2006/relationships" id="260" r:id="Rdc4e3708611e430f"/>
+    <p:sldId xmlns:r="http://schemas.openxmlformats.org/officeDocument/2006/relationships" id="261" r:id="R17eeae98158147d7"/>
+    <p:sldId xmlns:r="http://schemas.openxmlformats.org/officeDocument/2006/relationships" id="262" r:id="R9b8446fd61954c07"/>
+    <p:sldId xmlns:r="http://schemas.openxmlformats.org/officeDocument/2006/relationships" id="263" r:id="R7a80a0a24159466d"/>
+    <p:sldId xmlns:r="http://schemas.openxmlformats.org/officeDocument/2006/relationships" id="264" r:id="R369e330f961646e0"/>
+    <p:sldId xmlns:r="http://schemas.openxmlformats.org/officeDocument/2006/relationships" id="265" r:id="R496e3eab84434f9d"/>
   </p:sldIdLst>
   <p:sldSz cx="12192000" cy="6858000"/>
   <p:notesSz cx="6858000" cy="9144000"/>
@@ -1158,7 +1158,7 @@
   </p:cSld>
   <p:clrMap bg1="lt1" tx1="dk1" bg2="lt2" tx2="dk2" accent1="accent1" accent2="accent2" accent3="accent3" accent4="accent4" accent5="accent5" accent6="accent6" hlink="hlink" folHlink="folHlink"/>
   <p:sldLayoutIdLst>
-    <p:sldLayoutId xmlns:r="http://schemas.openxmlformats.org/officeDocument/2006/relationships" id="2147483649" r:id="R258cf6fdaca4457f"/>
+    <p:sldLayoutId xmlns:r="http://schemas.openxmlformats.org/officeDocument/2006/relationships" id="2147483649" r:id="Refdfb7ab5a8544cd"/>
   </p:sldLayoutIdLst>
   <p:txStyles>
     <p:titleStyle>
@@ -1461,7 +1461,7 @@
           <p:nvPr/>
         </p:nvPicPr>
         <p:blipFill>
-          <a:blip xmlns:r="http://schemas.openxmlformats.org/officeDocument/2006/relationships" xmlns:a="http://schemas.openxmlformats.org/drawingml/2006/main" r:embed="Re91eb82ebaa94e51"/>
+          <a:blip xmlns:r="http://schemas.openxmlformats.org/officeDocument/2006/relationships" xmlns:a="http://schemas.openxmlformats.org/drawingml/2006/main" r:embed="R720564c2fb6e4fa6"/>
           <a:srcRect xmlns:a="http://schemas.openxmlformats.org/drawingml/2006/main" l="0" t="27" r="0" b="27"/>
           <a:stretch xmlns:a="http://schemas.openxmlformats.org/drawingml/2006/main">
             <a:fillRect l="0" t="0" r="0" b="0"/>
@@ -1559,6 +1559,7 @@
           <a:lstStyle xmlns:a="http://schemas.openxmlformats.org/drawingml/2006/main"/>
           <a:p xmlns:a="http://schemas.openxmlformats.org/drawingml/2006/main">
             <a:pPr algn="l">
+              <a:buNone/>
               <a:defRPr sz="975" b="1" i="0">
                 <a:solidFill>
                   <a:srgbClr val="C8A66A"/>
@@ -1602,6 +1603,7 @@
           <a:lstStyle xmlns:a="http://schemas.openxmlformats.org/drawingml/2006/main"/>
           <a:p xmlns:a="http://schemas.openxmlformats.org/drawingml/2006/main">
             <a:pPr algn="l">
+              <a:buNone/>
               <a:defRPr sz="3450" b="0" i="0">
                 <a:solidFill>
                   <a:srgbClr val="F8F2E8"/>
@@ -1617,6 +1619,7 @@
           </a:p>
           <a:p xmlns:a="http://schemas.openxmlformats.org/drawingml/2006/main">
             <a:pPr algn="l">
+              <a:buNone/>
               <a:defRPr sz="3450" b="0" i="0">
                 <a:solidFill>
                   <a:srgbClr val="F8F2E8"/>
@@ -1660,6 +1663,7 @@
           <a:lstStyle xmlns:a="http://schemas.openxmlformats.org/drawingml/2006/main"/>
           <a:p xmlns:a="http://schemas.openxmlformats.org/drawingml/2006/main">
             <a:pPr algn="l">
+              <a:buNone/>
               <a:defRPr sz="1650" b="0" i="0">
                 <a:solidFill>
                   <a:srgbClr val="E9E0D0"/>
@@ -1740,6 +1744,7 @@
           <a:lstStyle xmlns:a="http://schemas.openxmlformats.org/drawingml/2006/main"/>
           <a:p xmlns:a="http://schemas.openxmlformats.org/drawingml/2006/main">
             <a:pPr algn="ctr">
+              <a:buNone/>
               <a:defRPr sz="975" b="1" i="0">
                 <a:solidFill>
                   <a:srgbClr val="C8A66A"/>
@@ -1820,6 +1825,7 @@
           <a:lstStyle xmlns:a="http://schemas.openxmlformats.org/drawingml/2006/main"/>
           <a:p xmlns:a="http://schemas.openxmlformats.org/drawingml/2006/main">
             <a:pPr algn="ctr">
+              <a:buNone/>
               <a:defRPr sz="975" b="1" i="0">
                 <a:solidFill>
                   <a:srgbClr val="C8A66A"/>
@@ -1900,6 +1906,7 @@
           <a:lstStyle xmlns:a="http://schemas.openxmlformats.org/drawingml/2006/main"/>
           <a:p xmlns:a="http://schemas.openxmlformats.org/drawingml/2006/main">
             <a:pPr algn="ctr">
+              <a:buNone/>
               <a:defRPr sz="975" b="1" i="0">
                 <a:solidFill>
                   <a:srgbClr val="C8A66A"/>
@@ -1980,6 +1987,7 @@
           <a:lstStyle xmlns:a="http://schemas.openxmlformats.org/drawingml/2006/main"/>
           <a:p xmlns:a="http://schemas.openxmlformats.org/drawingml/2006/main">
             <a:pPr algn="ctr">
+              <a:buNone/>
               <a:defRPr sz="975" b="1" i="0">
                 <a:solidFill>
                   <a:srgbClr val="C8A66A"/>
@@ -2023,6 +2031,7 @@
           <a:lstStyle xmlns:a="http://schemas.openxmlformats.org/drawingml/2006/main"/>
           <a:p xmlns:a="http://schemas.openxmlformats.org/drawingml/2006/main">
             <a:pPr algn="l">
+              <a:buNone/>
               <a:defRPr sz="1200" b="0" i="0">
                 <a:solidFill>
                   <a:srgbClr val="F8F2E8">
@@ -2097,6 +2106,7 @@
           <a:lstStyle xmlns:a="http://schemas.openxmlformats.org/drawingml/2006/main"/>
           <a:p xmlns:a="http://schemas.openxmlformats.org/drawingml/2006/main">
             <a:pPr algn="l">
+              <a:buNone/>
               <a:defRPr sz="825" b="1" i="0">
                 <a:solidFill>
                   <a:srgbClr val="F8F2E8">
@@ -2142,6 +2152,7 @@
           <a:lstStyle xmlns:a="http://schemas.openxmlformats.org/drawingml/2006/main"/>
           <a:p xmlns:a="http://schemas.openxmlformats.org/drawingml/2006/main">
             <a:pPr algn="r">
+              <a:buNone/>
               <a:defRPr sz="900" b="0" i="0">
                 <a:solidFill>
                   <a:srgbClr val="F8F2E8">
@@ -2263,6 +2274,7 @@
           <a:lstStyle xmlns:a="http://schemas.openxmlformats.org/drawingml/2006/main"/>
           <a:p xmlns:a="http://schemas.openxmlformats.org/drawingml/2006/main">
             <a:pPr algn="l">
+              <a:buNone/>
               <a:defRPr sz="975" b="1" i="0">
                 <a:solidFill>
                   <a:srgbClr val="C8A66A"/>
@@ -2306,6 +2318,7 @@
           <a:lstStyle xmlns:a="http://schemas.openxmlformats.org/drawingml/2006/main"/>
           <a:p xmlns:a="http://schemas.openxmlformats.org/drawingml/2006/main">
             <a:pPr algn="l">
+              <a:buNone/>
               <a:defRPr sz="3450" b="0" i="0">
                 <a:solidFill>
                   <a:srgbClr val="F8F2E8"/>
@@ -2349,6 +2362,7 @@
           <a:lstStyle xmlns:a="http://schemas.openxmlformats.org/drawingml/2006/main"/>
           <a:p xmlns:a="http://schemas.openxmlformats.org/drawingml/2006/main">
             <a:pPr algn="l">
+              <a:buNone/>
               <a:defRPr sz="1650" b="0" i="0">
                 <a:solidFill>
                   <a:srgbClr val="E9E0D0"/>
@@ -2460,6 +2474,7 @@
           <a:lstStyle xmlns:a="http://schemas.openxmlformats.org/drawingml/2006/main"/>
           <a:p xmlns:a="http://schemas.openxmlformats.org/drawingml/2006/main">
             <a:pPr algn="ctr">
+              <a:buNone/>
               <a:defRPr sz="1350" b="1" i="0">
                 <a:solidFill>
                   <a:srgbClr val="C8A66A"/>
@@ -2503,6 +2518,7 @@
           <a:lstStyle xmlns:a="http://schemas.openxmlformats.org/drawingml/2006/main"/>
           <a:p xmlns:a="http://schemas.openxmlformats.org/drawingml/2006/main">
             <a:pPr algn="ctr">
+              <a:buNone/>
               <a:defRPr sz="1425" b="1" i="0">
                 <a:solidFill>
                   <a:srgbClr val="F8F2E8"/>
@@ -2546,6 +2562,7 @@
           <a:lstStyle xmlns:a="http://schemas.openxmlformats.org/drawingml/2006/main"/>
           <a:p xmlns:a="http://schemas.openxmlformats.org/drawingml/2006/main">
             <a:pPr algn="ctr">
+              <a:buNone/>
               <a:defRPr sz="1050" b="0" i="0">
                 <a:solidFill>
                   <a:srgbClr val="D9CEBE"/>
@@ -2628,6 +2645,7 @@
           <a:lstStyle xmlns:a="http://schemas.openxmlformats.org/drawingml/2006/main"/>
           <a:p xmlns:a="http://schemas.openxmlformats.org/drawingml/2006/main">
             <a:pPr algn="ctr">
+              <a:buNone/>
               <a:defRPr sz="1350" b="1" i="0">
                 <a:solidFill>
                   <a:srgbClr val="C8A66A"/>
@@ -2671,6 +2689,7 @@
           <a:lstStyle xmlns:a="http://schemas.openxmlformats.org/drawingml/2006/main"/>
           <a:p xmlns:a="http://schemas.openxmlformats.org/drawingml/2006/main">
             <a:pPr algn="ctr">
+              <a:buNone/>
               <a:defRPr sz="1425" b="1" i="0">
                 <a:solidFill>
                   <a:srgbClr val="F8F2E8"/>
@@ -2714,6 +2733,7 @@
           <a:lstStyle xmlns:a="http://schemas.openxmlformats.org/drawingml/2006/main"/>
           <a:p xmlns:a="http://schemas.openxmlformats.org/drawingml/2006/main">
             <a:pPr algn="ctr">
+              <a:buNone/>
               <a:defRPr sz="1050" b="0" i="0">
                 <a:solidFill>
                   <a:srgbClr val="D9CEBE"/>
@@ -2796,6 +2816,7 @@
           <a:lstStyle xmlns:a="http://schemas.openxmlformats.org/drawingml/2006/main"/>
           <a:p xmlns:a="http://schemas.openxmlformats.org/drawingml/2006/main">
             <a:pPr algn="ctr">
+              <a:buNone/>
               <a:defRPr sz="1350" b="1" i="0">
                 <a:solidFill>
                   <a:srgbClr val="C8A66A"/>
@@ -2839,6 +2860,7 @@
           <a:lstStyle xmlns:a="http://schemas.openxmlformats.org/drawingml/2006/main"/>
           <a:p xmlns:a="http://schemas.openxmlformats.org/drawingml/2006/main">
             <a:pPr algn="ctr">
+              <a:buNone/>
               <a:defRPr sz="1425" b="1" i="0">
                 <a:solidFill>
                   <a:srgbClr val="F8F2E8"/>
@@ -2882,6 +2904,7 @@
           <a:lstStyle xmlns:a="http://schemas.openxmlformats.org/drawingml/2006/main"/>
           <a:p xmlns:a="http://schemas.openxmlformats.org/drawingml/2006/main">
             <a:pPr algn="ctr">
+              <a:buNone/>
               <a:defRPr sz="1050" b="0" i="0">
                 <a:solidFill>
                   <a:srgbClr val="D9CEBE"/>
@@ -2964,6 +2987,7 @@
           <a:lstStyle xmlns:a="http://schemas.openxmlformats.org/drawingml/2006/main"/>
           <a:p xmlns:a="http://schemas.openxmlformats.org/drawingml/2006/main">
             <a:pPr algn="ctr">
+              <a:buNone/>
               <a:defRPr sz="1350" b="1" i="0">
                 <a:solidFill>
                   <a:srgbClr val="C8A66A"/>
@@ -3007,6 +3031,7 @@
           <a:lstStyle xmlns:a="http://schemas.openxmlformats.org/drawingml/2006/main"/>
           <a:p xmlns:a="http://schemas.openxmlformats.org/drawingml/2006/main">
             <a:pPr algn="ctr">
+              <a:buNone/>
               <a:defRPr sz="1425" b="1" i="0">
                 <a:solidFill>
                   <a:srgbClr val="F8F2E8"/>
@@ -3050,6 +3075,7 @@
           <a:lstStyle xmlns:a="http://schemas.openxmlformats.org/drawingml/2006/main"/>
           <a:p xmlns:a="http://schemas.openxmlformats.org/drawingml/2006/main">
             <a:pPr algn="ctr">
+              <a:buNone/>
               <a:defRPr sz="1050" b="0" i="0">
                 <a:solidFill>
                   <a:srgbClr val="D9CEBE"/>
@@ -3132,6 +3158,7 @@
           <a:lstStyle xmlns:a="http://schemas.openxmlformats.org/drawingml/2006/main"/>
           <a:p xmlns:a="http://schemas.openxmlformats.org/drawingml/2006/main">
             <a:pPr algn="ctr">
+              <a:buNone/>
               <a:defRPr sz="1350" b="1" i="0">
                 <a:solidFill>
                   <a:srgbClr val="C8A66A"/>
@@ -3175,6 +3202,7 @@
           <a:lstStyle xmlns:a="http://schemas.openxmlformats.org/drawingml/2006/main"/>
           <a:p xmlns:a="http://schemas.openxmlformats.org/drawingml/2006/main">
             <a:pPr algn="ctr">
+              <a:buNone/>
               <a:defRPr sz="1425" b="1" i="0">
                 <a:solidFill>
                   <a:srgbClr val="F8F2E8"/>
@@ -3218,6 +3246,7 @@
           <a:lstStyle xmlns:a="http://schemas.openxmlformats.org/drawingml/2006/main"/>
           <a:p xmlns:a="http://schemas.openxmlformats.org/drawingml/2006/main">
             <a:pPr algn="ctr">
+              <a:buNone/>
               <a:defRPr sz="1050" b="0" i="0">
                 <a:solidFill>
                   <a:srgbClr val="D9CEBE"/>
@@ -3300,6 +3329,7 @@
           <a:lstStyle xmlns:a="http://schemas.openxmlformats.org/drawingml/2006/main"/>
           <a:p xmlns:a="http://schemas.openxmlformats.org/drawingml/2006/main">
             <a:pPr algn="ctr">
+              <a:buNone/>
               <a:defRPr sz="975" b="1" i="0">
                 <a:solidFill>
                   <a:srgbClr val="F3E8D8"/>
@@ -3372,6 +3402,7 @@
           <a:lstStyle xmlns:a="http://schemas.openxmlformats.org/drawingml/2006/main"/>
           <a:p xmlns:a="http://schemas.openxmlformats.org/drawingml/2006/main">
             <a:pPr algn="l">
+              <a:buNone/>
               <a:defRPr sz="825" b="1" i="0">
                 <a:solidFill>
                   <a:srgbClr val="F8F2E8">
@@ -3417,6 +3448,7 @@
           <a:lstStyle xmlns:a="http://schemas.openxmlformats.org/drawingml/2006/main"/>
           <a:p xmlns:a="http://schemas.openxmlformats.org/drawingml/2006/main">
             <a:pPr algn="r">
+              <a:buNone/>
               <a:defRPr sz="900" b="0" i="0">
                 <a:solidFill>
                   <a:srgbClr val="F8F2E8">
@@ -3538,6 +3570,7 @@
           <a:lstStyle xmlns:a="http://schemas.openxmlformats.org/drawingml/2006/main"/>
           <a:p xmlns:a="http://schemas.openxmlformats.org/drawingml/2006/main">
             <a:pPr algn="l">
+              <a:buNone/>
               <a:defRPr sz="975" b="1" i="0">
                 <a:solidFill>
                   <a:srgbClr val="C8A66A"/>
@@ -3581,6 +3614,7 @@
           <a:lstStyle xmlns:a="http://schemas.openxmlformats.org/drawingml/2006/main"/>
           <a:p xmlns:a="http://schemas.openxmlformats.org/drawingml/2006/main">
             <a:pPr algn="l">
+              <a:buNone/>
               <a:defRPr sz="3450" b="0" i="0">
                 <a:solidFill>
                   <a:srgbClr val="F8F2E8"/>
@@ -3624,6 +3658,7 @@
           <a:lstStyle xmlns:a="http://schemas.openxmlformats.org/drawingml/2006/main"/>
           <a:p xmlns:a="http://schemas.openxmlformats.org/drawingml/2006/main">
             <a:pPr algn="l">
+              <a:buNone/>
               <a:defRPr sz="1650" b="0" i="0">
                 <a:solidFill>
                   <a:srgbClr val="E9E0D0"/>
@@ -3706,6 +3741,7 @@
           <a:lstStyle xmlns:a="http://schemas.openxmlformats.org/drawingml/2006/main"/>
           <a:p xmlns:a="http://schemas.openxmlformats.org/drawingml/2006/main">
             <a:pPr algn="ctr">
+              <a:buNone/>
               <a:defRPr sz="1200" b="1" i="0">
                 <a:solidFill>
                   <a:srgbClr val="F8F2E8"/>
@@ -3817,6 +3853,7 @@
           <a:lstStyle xmlns:a="http://schemas.openxmlformats.org/drawingml/2006/main"/>
           <a:p xmlns:a="http://schemas.openxmlformats.org/drawingml/2006/main">
             <a:pPr algn="ctr">
+              <a:buNone/>
               <a:defRPr sz="1200" b="1" i="0">
                 <a:solidFill>
                   <a:srgbClr val="F8F2E8"/>
@@ -3928,6 +3965,7 @@
           <a:lstStyle xmlns:a="http://schemas.openxmlformats.org/drawingml/2006/main"/>
           <a:p xmlns:a="http://schemas.openxmlformats.org/drawingml/2006/main">
             <a:pPr algn="ctr">
+              <a:buNone/>
               <a:defRPr sz="1200" b="1" i="0">
                 <a:solidFill>
                   <a:srgbClr val="F8F2E8"/>
@@ -4039,6 +4077,7 @@
           <a:lstStyle xmlns:a="http://schemas.openxmlformats.org/drawingml/2006/main"/>
           <a:p xmlns:a="http://schemas.openxmlformats.org/drawingml/2006/main">
             <a:pPr algn="ctr">
+              <a:buNone/>
               <a:defRPr sz="1200" b="1" i="0">
                 <a:solidFill>
                   <a:srgbClr val="F8F2E8"/>
@@ -4150,6 +4189,7 @@
           <a:lstStyle xmlns:a="http://schemas.openxmlformats.org/drawingml/2006/main"/>
           <a:p xmlns:a="http://schemas.openxmlformats.org/drawingml/2006/main">
             <a:pPr algn="l">
+              <a:buNone/>
               <a:defRPr sz="3900" b="0" i="0">
                 <a:solidFill>
                   <a:srgbClr val="C8A66A"/>
@@ -4193,6 +4233,7 @@
           <a:lstStyle xmlns:a="http://schemas.openxmlformats.org/drawingml/2006/main"/>
           <a:p xmlns:a="http://schemas.openxmlformats.org/drawingml/2006/main">
             <a:pPr algn="l">
+              <a:buNone/>
               <a:defRPr sz="1650" b="0" i="0">
                 <a:solidFill>
                   <a:srgbClr val="F8F2E8"/>
@@ -4275,6 +4316,7 @@
           <a:lstStyle xmlns:a="http://schemas.openxmlformats.org/drawingml/2006/main"/>
           <a:p xmlns:a="http://schemas.openxmlformats.org/drawingml/2006/main">
             <a:pPr algn="l">
+              <a:buNone/>
               <a:defRPr sz="1575" b="1" i="0">
                 <a:solidFill>
                   <a:srgbClr val="F8F2E8"/>
@@ -4318,6 +4360,7 @@
           <a:lstStyle xmlns:a="http://schemas.openxmlformats.org/drawingml/2006/main"/>
           <a:p xmlns:a="http://schemas.openxmlformats.org/drawingml/2006/main">
             <a:pPr algn="l">
+              <a:buNone/>
               <a:defRPr sz="1200" b="0" i="0">
                 <a:solidFill>
                   <a:srgbClr val="DFD4C3"/>
@@ -4390,6 +4433,7 @@
           <a:lstStyle xmlns:a="http://schemas.openxmlformats.org/drawingml/2006/main"/>
           <a:p xmlns:a="http://schemas.openxmlformats.org/drawingml/2006/main">
             <a:pPr algn="l">
+              <a:buNone/>
               <a:defRPr sz="825" b="1" i="0">
                 <a:solidFill>
                   <a:srgbClr val="F8F2E8">
@@ -4435,6 +4479,7 @@
           <a:lstStyle xmlns:a="http://schemas.openxmlformats.org/drawingml/2006/main"/>
           <a:p xmlns:a="http://schemas.openxmlformats.org/drawingml/2006/main">
             <a:pPr algn="r">
+              <a:buNone/>
               <a:defRPr sz="900" b="0" i="0">
                 <a:solidFill>
                   <a:srgbClr val="F8F2E8">
@@ -4556,6 +4601,7 @@
           <a:lstStyle xmlns:a="http://schemas.openxmlformats.org/drawingml/2006/main"/>
           <a:p xmlns:a="http://schemas.openxmlformats.org/drawingml/2006/main">
             <a:pPr algn="l">
+              <a:buNone/>
               <a:defRPr sz="975" b="1" i="0">
                 <a:solidFill>
                   <a:srgbClr val="C8A66A"/>
@@ -4599,6 +4645,7 @@
           <a:lstStyle xmlns:a="http://schemas.openxmlformats.org/drawingml/2006/main"/>
           <a:p xmlns:a="http://schemas.openxmlformats.org/drawingml/2006/main">
             <a:pPr algn="l">
+              <a:buNone/>
               <a:defRPr sz="3450" b="0" i="0">
                 <a:solidFill>
                   <a:srgbClr val="F8F2E8"/>
@@ -4642,6 +4689,7 @@
           <a:lstStyle xmlns:a="http://schemas.openxmlformats.org/drawingml/2006/main"/>
           <a:p xmlns:a="http://schemas.openxmlformats.org/drawingml/2006/main">
             <a:pPr algn="l">
+              <a:buNone/>
               <a:defRPr sz="1650" b="0" i="0">
                 <a:solidFill>
                   <a:srgbClr val="E9E0D0"/>
@@ -4685,6 +4733,7 @@
           <a:lstStyle xmlns:a="http://schemas.openxmlformats.org/drawingml/2006/main"/>
           <a:p xmlns:a="http://schemas.openxmlformats.org/drawingml/2006/main">
             <a:pPr algn="l">
+              <a:buNone/>
               <a:defRPr sz="1350" b="1" i="0">
                 <a:solidFill>
                   <a:srgbClr val="D8C8B6"/>
@@ -4728,6 +4777,7 @@
           <a:lstStyle xmlns:a="http://schemas.openxmlformats.org/drawingml/2006/main"/>
           <a:p xmlns:a="http://schemas.openxmlformats.org/drawingml/2006/main">
             <a:pPr algn="l">
+              <a:buNone/>
               <a:defRPr sz="1350" b="1" i="0">
                 <a:solidFill>
                   <a:srgbClr val="D8C8B6"/>
@@ -4810,6 +4860,7 @@
           <a:lstStyle xmlns:a="http://schemas.openxmlformats.org/drawingml/2006/main"/>
           <a:p xmlns:a="http://schemas.openxmlformats.org/drawingml/2006/main">
             <a:pPr algn="l">
+              <a:buNone/>
               <a:defRPr sz="1125" b="1" i="0">
                 <a:solidFill>
                   <a:srgbClr val="F1E7D7"/>
@@ -4853,6 +4904,7 @@
           <a:lstStyle xmlns:a="http://schemas.openxmlformats.org/drawingml/2006/main"/>
           <a:p xmlns:a="http://schemas.openxmlformats.org/drawingml/2006/main">
             <a:pPr algn="l">
+              <a:buNone/>
               <a:defRPr sz="1050" b="0" i="0">
                 <a:solidFill>
                   <a:srgbClr val="CDBEA9"/>
@@ -4935,6 +4987,7 @@
           <a:lstStyle xmlns:a="http://schemas.openxmlformats.org/drawingml/2006/main"/>
           <a:p xmlns:a="http://schemas.openxmlformats.org/drawingml/2006/main">
             <a:pPr algn="l">
+              <a:buNone/>
               <a:defRPr sz="1125" b="1" i="0">
                 <a:solidFill>
                   <a:srgbClr val="F1E7D7"/>
@@ -4978,6 +5031,7 @@
           <a:lstStyle xmlns:a="http://schemas.openxmlformats.org/drawingml/2006/main"/>
           <a:p xmlns:a="http://schemas.openxmlformats.org/drawingml/2006/main">
             <a:pPr algn="l">
+              <a:buNone/>
               <a:defRPr sz="1050" b="0" i="0">
                 <a:solidFill>
                   <a:srgbClr val="CDBEA9"/>
@@ -5060,6 +5114,7 @@
           <a:lstStyle xmlns:a="http://schemas.openxmlformats.org/drawingml/2006/main"/>
           <a:p xmlns:a="http://schemas.openxmlformats.org/drawingml/2006/main">
             <a:pPr algn="l">
+              <a:buNone/>
               <a:defRPr sz="1125" b="1" i="0">
                 <a:solidFill>
                   <a:srgbClr val="F1E7D7"/>
@@ -5103,6 +5158,7 @@
           <a:lstStyle xmlns:a="http://schemas.openxmlformats.org/drawingml/2006/main"/>
           <a:p xmlns:a="http://schemas.openxmlformats.org/drawingml/2006/main">
             <a:pPr algn="l">
+              <a:buNone/>
               <a:defRPr sz="1050" b="0" i="0">
                 <a:solidFill>
                   <a:srgbClr val="CDBEA9"/>
@@ -5185,6 +5241,7 @@
           <a:lstStyle xmlns:a="http://schemas.openxmlformats.org/drawingml/2006/main"/>
           <a:p xmlns:a="http://schemas.openxmlformats.org/drawingml/2006/main">
             <a:pPr algn="l">
+              <a:buNone/>
               <a:defRPr sz="1125" b="1" i="0">
                 <a:solidFill>
                   <a:srgbClr val="F1E7D7"/>
@@ -5228,6 +5285,7 @@
           <a:lstStyle xmlns:a="http://schemas.openxmlformats.org/drawingml/2006/main"/>
           <a:p xmlns:a="http://schemas.openxmlformats.org/drawingml/2006/main">
             <a:pPr algn="l">
+              <a:buNone/>
               <a:defRPr sz="1050" b="0" i="0">
                 <a:solidFill>
                   <a:srgbClr val="CDBEA9"/>
@@ -5310,6 +5368,7 @@
           <a:lstStyle xmlns:a="http://schemas.openxmlformats.org/drawingml/2006/main"/>
           <a:p xmlns:a="http://schemas.openxmlformats.org/drawingml/2006/main">
             <a:pPr algn="l">
+              <a:buNone/>
               <a:defRPr sz="1125" b="1" i="0">
                 <a:solidFill>
                   <a:srgbClr val="FFE6AE"/>
@@ -5353,6 +5412,7 @@
           <a:lstStyle xmlns:a="http://schemas.openxmlformats.org/drawingml/2006/main"/>
           <a:p xmlns:a="http://schemas.openxmlformats.org/drawingml/2006/main">
             <a:pPr algn="l">
+              <a:buNone/>
               <a:defRPr sz="1050" b="0" i="0">
                 <a:solidFill>
                   <a:srgbClr val="F5EBD9"/>
@@ -5435,6 +5495,7 @@
           <a:lstStyle xmlns:a="http://schemas.openxmlformats.org/drawingml/2006/main"/>
           <a:p xmlns:a="http://schemas.openxmlformats.org/drawingml/2006/main">
             <a:pPr algn="l">
+              <a:buNone/>
               <a:defRPr sz="1125" b="1" i="0">
                 <a:solidFill>
                   <a:srgbClr val="FFE6AE"/>
@@ -5478,6 +5539,7 @@
           <a:lstStyle xmlns:a="http://schemas.openxmlformats.org/drawingml/2006/main"/>
           <a:p xmlns:a="http://schemas.openxmlformats.org/drawingml/2006/main">
             <a:pPr algn="l">
+              <a:buNone/>
               <a:defRPr sz="1050" b="0" i="0">
                 <a:solidFill>
                   <a:srgbClr val="F5EBD9"/>
@@ -5560,6 +5622,7 @@
           <a:lstStyle xmlns:a="http://schemas.openxmlformats.org/drawingml/2006/main"/>
           <a:p xmlns:a="http://schemas.openxmlformats.org/drawingml/2006/main">
             <a:pPr algn="l">
+              <a:buNone/>
               <a:defRPr sz="1125" b="1" i="0">
                 <a:solidFill>
                   <a:srgbClr val="FFE6AE"/>
@@ -5603,6 +5666,7 @@
           <a:lstStyle xmlns:a="http://schemas.openxmlformats.org/drawingml/2006/main"/>
           <a:p xmlns:a="http://schemas.openxmlformats.org/drawingml/2006/main">
             <a:pPr algn="l">
+              <a:buNone/>
               <a:defRPr sz="1050" b="0" i="0">
                 <a:solidFill>
                   <a:srgbClr val="F5EBD9"/>
@@ -5685,6 +5749,7 @@
           <a:lstStyle xmlns:a="http://schemas.openxmlformats.org/drawingml/2006/main"/>
           <a:p xmlns:a="http://schemas.openxmlformats.org/drawingml/2006/main">
             <a:pPr algn="l">
+              <a:buNone/>
               <a:defRPr sz="1125" b="1" i="0">
                 <a:solidFill>
                   <a:srgbClr val="FFE6AE"/>
@@ -5728,6 +5793,7 @@
           <a:lstStyle xmlns:a="http://schemas.openxmlformats.org/drawingml/2006/main"/>
           <a:p xmlns:a="http://schemas.openxmlformats.org/drawingml/2006/main">
             <a:pPr algn="l">
+              <a:buNone/>
               <a:defRPr sz="1050" b="0" i="0">
                 <a:solidFill>
                   <a:srgbClr val="F5EBD9"/>
@@ -5798,6 +5864,7 @@
           <a:lstStyle xmlns:a="http://schemas.openxmlformats.org/drawingml/2006/main"/>
           <a:p xmlns:a="http://schemas.openxmlformats.org/drawingml/2006/main">
             <a:pPr algn="ctr">
+              <a:buNone/>
               <a:defRPr sz="1125" b="1" i="0">
                 <a:solidFill>
                   <a:srgbClr val="C8A66A"/>
@@ -5870,6 +5937,7 @@
           <a:lstStyle xmlns:a="http://schemas.openxmlformats.org/drawingml/2006/main"/>
           <a:p xmlns:a="http://schemas.openxmlformats.org/drawingml/2006/main">
             <a:pPr algn="l">
+              <a:buNone/>
               <a:defRPr sz="825" b="1" i="0">
                 <a:solidFill>
                   <a:srgbClr val="F8F2E8">
@@ -5915,6 +5983,7 @@
           <a:lstStyle xmlns:a="http://schemas.openxmlformats.org/drawingml/2006/main"/>
           <a:p xmlns:a="http://schemas.openxmlformats.org/drawingml/2006/main">
             <a:pPr algn="r">
+              <a:buNone/>
               <a:defRPr sz="900" b="0" i="0">
                 <a:solidFill>
                   <a:srgbClr val="F8F2E8">
@@ -5963,7 +6032,7 @@
           <p:nvPr/>
         </p:nvPicPr>
         <p:blipFill>
-          <a:blip xmlns:r="http://schemas.openxmlformats.org/officeDocument/2006/relationships" xmlns:a="http://schemas.openxmlformats.org/drawingml/2006/main" r:embed="R80582344043c49bb"/>
+          <a:blip xmlns:r="http://schemas.openxmlformats.org/officeDocument/2006/relationships" xmlns:a="http://schemas.openxmlformats.org/drawingml/2006/main" r:embed="R2fd7f9ad6f3348a4"/>
           <a:srcRect xmlns:a="http://schemas.openxmlformats.org/drawingml/2006/main" l="0" t="27" r="0" b="27"/>
           <a:stretch xmlns:a="http://schemas.openxmlformats.org/drawingml/2006/main">
             <a:fillRect l="0" t="0" r="0" b="0"/>
@@ -6073,6 +6142,7 @@
           <a:lstStyle xmlns:a="http://schemas.openxmlformats.org/drawingml/2006/main"/>
           <a:p xmlns:a="http://schemas.openxmlformats.org/drawingml/2006/main">
             <a:pPr algn="l">
+              <a:buNone/>
               <a:defRPr sz="975" b="1" i="0">
                 <a:solidFill>
                   <a:srgbClr val="C8A66A"/>
@@ -6116,6 +6186,7 @@
           <a:lstStyle xmlns:a="http://schemas.openxmlformats.org/drawingml/2006/main"/>
           <a:p xmlns:a="http://schemas.openxmlformats.org/drawingml/2006/main">
             <a:pPr algn="l">
+              <a:buNone/>
               <a:defRPr sz="3450" b="0" i="0">
                 <a:solidFill>
                   <a:srgbClr val="F8F2E8"/>
@@ -6159,6 +6230,7 @@
           <a:lstStyle xmlns:a="http://schemas.openxmlformats.org/drawingml/2006/main"/>
           <a:p xmlns:a="http://schemas.openxmlformats.org/drawingml/2006/main">
             <a:pPr algn="l">
+              <a:buNone/>
               <a:defRPr sz="1650" b="0" i="0">
                 <a:solidFill>
                   <a:srgbClr val="E9E0D0"/>
@@ -6191,7 +6263,7 @@
         <p:spPr>
           <a:xfrm xmlns:a="http://schemas.openxmlformats.org/drawingml/2006/main">
             <a:off x="952500" y="4324350"/>
-            <a:ext cx="3695700" cy="838200"/>
+            <a:ext cx="3695700" cy="1219200"/>
           </a:xfrm>
           <a:prstGeom xmlns:a="http://schemas.openxmlformats.org/drawingml/2006/main" prst="roundRect">
             <a:avLst>
@@ -6229,7 +6301,7 @@
         </p:nvSpPr>
         <p:spPr>
           <a:xfrm xmlns:a="http://schemas.openxmlformats.org/drawingml/2006/main">
-            <a:off x="1181100" y="4533900"/>
+            <a:off x="1181100" y="4514850"/>
             <a:ext cx="3238500" cy="323850"/>
           </a:xfrm>
           <a:prstGeom xmlns:a="http://schemas.openxmlformats.org/drawingml/2006/main" prst="rect">
@@ -6241,6 +6313,7 @@
           <a:lstStyle xmlns:a="http://schemas.openxmlformats.org/drawingml/2006/main"/>
           <a:p xmlns:a="http://schemas.openxmlformats.org/drawingml/2006/main">
             <a:pPr algn="l">
+              <a:buNone/>
               <a:defRPr sz="1575" b="1" i="0">
                 <a:solidFill>
                   <a:srgbClr val="F8F2E8"/>
@@ -6272,8 +6345,8 @@
         </p:nvSpPr>
         <p:spPr>
           <a:xfrm xmlns:a="http://schemas.openxmlformats.org/drawingml/2006/main">
-            <a:off x="1181100" y="4953000"/>
-            <a:ext cx="3238500" cy="57150"/>
+            <a:off x="1181100" y="4933950"/>
+            <a:ext cx="3238500" cy="514350"/>
           </a:xfrm>
           <a:prstGeom xmlns:a="http://schemas.openxmlformats.org/drawingml/2006/main" prst="rect">
             <a:avLst/>
@@ -6284,6 +6357,7 @@
           <a:lstStyle xmlns:a="http://schemas.openxmlformats.org/drawingml/2006/main"/>
           <a:p xmlns:a="http://schemas.openxmlformats.org/drawingml/2006/main">
             <a:pPr algn="l">
+              <a:buNone/>
               <a:defRPr sz="1125" b="0" i="0">
                 <a:solidFill>
                   <a:srgbClr val="DFD4C3"/>
@@ -6356,6 +6430,7 @@
           <a:lstStyle xmlns:a="http://schemas.openxmlformats.org/drawingml/2006/main"/>
           <a:p xmlns:a="http://schemas.openxmlformats.org/drawingml/2006/main">
             <a:pPr algn="l">
+              <a:buNone/>
               <a:defRPr sz="825" b="1" i="0">
                 <a:solidFill>
                   <a:srgbClr val="F8F2E8">
@@ -6401,6 +6476,7 @@
           <a:lstStyle xmlns:a="http://schemas.openxmlformats.org/drawingml/2006/main"/>
           <a:p xmlns:a="http://schemas.openxmlformats.org/drawingml/2006/main">
             <a:pPr algn="r">
+              <a:buNone/>
               <a:defRPr sz="900" b="0" i="0">
                 <a:solidFill>
                   <a:srgbClr val="F8F2E8">
@@ -6522,6 +6598,7 @@
           <a:lstStyle xmlns:a="http://schemas.openxmlformats.org/drawingml/2006/main"/>
           <a:p xmlns:a="http://schemas.openxmlformats.org/drawingml/2006/main">
             <a:pPr algn="l">
+              <a:buNone/>
               <a:defRPr sz="975" b="1" i="0">
                 <a:solidFill>
                   <a:srgbClr val="C8A66A"/>
@@ -6565,6 +6642,7 @@
           <a:lstStyle xmlns:a="http://schemas.openxmlformats.org/drawingml/2006/main"/>
           <a:p xmlns:a="http://schemas.openxmlformats.org/drawingml/2006/main">
             <a:pPr algn="l">
+              <a:buNone/>
               <a:defRPr sz="3450" b="0" i="0">
                 <a:solidFill>
                   <a:srgbClr val="F8F2E8"/>
@@ -6608,6 +6686,7 @@
           <a:lstStyle xmlns:a="http://schemas.openxmlformats.org/drawingml/2006/main"/>
           <a:p xmlns:a="http://schemas.openxmlformats.org/drawingml/2006/main">
             <a:pPr algn="l">
+              <a:buNone/>
               <a:defRPr sz="1650" b="0" i="0">
                 <a:solidFill>
                   <a:srgbClr val="E9E0D0"/>
@@ -6729,6 +6808,7 @@
           <a:lstStyle xmlns:a="http://schemas.openxmlformats.org/drawingml/2006/main"/>
           <a:p xmlns:a="http://schemas.openxmlformats.org/drawingml/2006/main">
             <a:pPr algn="ctr">
+              <a:buNone/>
               <a:defRPr sz="1350" b="1" i="0">
                 <a:solidFill>
                   <a:srgbClr val="C8A66A"/>
@@ -6772,6 +6852,7 @@
           <a:lstStyle xmlns:a="http://schemas.openxmlformats.org/drawingml/2006/main"/>
           <a:p xmlns:a="http://schemas.openxmlformats.org/drawingml/2006/main">
             <a:pPr algn="l">
+              <a:buNone/>
               <a:defRPr sz="1500" b="1" i="0">
                 <a:solidFill>
                   <a:srgbClr val="F8F2E8"/>
@@ -6815,6 +6896,7 @@
           <a:lstStyle xmlns:a="http://schemas.openxmlformats.org/drawingml/2006/main"/>
           <a:p xmlns:a="http://schemas.openxmlformats.org/drawingml/2006/main">
             <a:pPr algn="l">
+              <a:buNone/>
               <a:defRPr sz="1125" b="0" i="0">
                 <a:solidFill>
                   <a:srgbClr val="D9CEBE"/>
@@ -6965,6 +7047,7 @@
           <a:lstStyle xmlns:a="http://schemas.openxmlformats.org/drawingml/2006/main"/>
           <a:p xmlns:a="http://schemas.openxmlformats.org/drawingml/2006/main">
             <a:pPr algn="ctr">
+              <a:buNone/>
               <a:defRPr sz="1350" b="1" i="0">
                 <a:solidFill>
                   <a:srgbClr val="C8A66A"/>
@@ -7008,6 +7091,7 @@
           <a:lstStyle xmlns:a="http://schemas.openxmlformats.org/drawingml/2006/main"/>
           <a:p xmlns:a="http://schemas.openxmlformats.org/drawingml/2006/main">
             <a:pPr algn="l">
+              <a:buNone/>
               <a:defRPr sz="1500" b="1" i="0">
                 <a:solidFill>
                   <a:srgbClr val="F8F2E8"/>
@@ -7051,6 +7135,7 @@
           <a:lstStyle xmlns:a="http://schemas.openxmlformats.org/drawingml/2006/main"/>
           <a:p xmlns:a="http://schemas.openxmlformats.org/drawingml/2006/main">
             <a:pPr algn="l">
+              <a:buNone/>
               <a:defRPr sz="1125" b="0" i="0">
                 <a:solidFill>
                   <a:srgbClr val="D9CEBE"/>
@@ -7201,6 +7286,7 @@
           <a:lstStyle xmlns:a="http://schemas.openxmlformats.org/drawingml/2006/main"/>
           <a:p xmlns:a="http://schemas.openxmlformats.org/drawingml/2006/main">
             <a:pPr algn="ctr">
+              <a:buNone/>
               <a:defRPr sz="1350" b="1" i="0">
                 <a:solidFill>
                   <a:srgbClr val="C8A66A"/>
@@ -7244,6 +7330,7 @@
           <a:lstStyle xmlns:a="http://schemas.openxmlformats.org/drawingml/2006/main"/>
           <a:p xmlns:a="http://schemas.openxmlformats.org/drawingml/2006/main">
             <a:pPr algn="l">
+              <a:buNone/>
               <a:defRPr sz="1500" b="1" i="0">
                 <a:solidFill>
                   <a:srgbClr val="F8F2E8"/>
@@ -7287,6 +7374,7 @@
           <a:lstStyle xmlns:a="http://schemas.openxmlformats.org/drawingml/2006/main"/>
           <a:p xmlns:a="http://schemas.openxmlformats.org/drawingml/2006/main">
             <a:pPr algn="l">
+              <a:buNone/>
               <a:defRPr sz="1125" b="0" i="0">
                 <a:solidFill>
                   <a:srgbClr val="D9CEBE"/>
@@ -7437,6 +7525,7 @@
           <a:lstStyle xmlns:a="http://schemas.openxmlformats.org/drawingml/2006/main"/>
           <a:p xmlns:a="http://schemas.openxmlformats.org/drawingml/2006/main">
             <a:pPr algn="ctr">
+              <a:buNone/>
               <a:defRPr sz="1350" b="1" i="0">
                 <a:solidFill>
                   <a:srgbClr val="C8A66A"/>
@@ -7480,6 +7569,7 @@
           <a:lstStyle xmlns:a="http://schemas.openxmlformats.org/drawingml/2006/main"/>
           <a:p xmlns:a="http://schemas.openxmlformats.org/drawingml/2006/main">
             <a:pPr algn="l">
+              <a:buNone/>
               <a:defRPr sz="1500" b="1" i="0">
                 <a:solidFill>
                   <a:srgbClr val="F8F2E8"/>
@@ -7523,6 +7613,7 @@
           <a:lstStyle xmlns:a="http://schemas.openxmlformats.org/drawingml/2006/main"/>
           <a:p xmlns:a="http://schemas.openxmlformats.org/drawingml/2006/main">
             <a:pPr algn="l">
+              <a:buNone/>
               <a:defRPr sz="1125" b="0" i="0">
                 <a:solidFill>
                   <a:srgbClr val="D9CEBE"/>
@@ -7595,6 +7686,7 @@
           <a:lstStyle xmlns:a="http://schemas.openxmlformats.org/drawingml/2006/main"/>
           <a:p xmlns:a="http://schemas.openxmlformats.org/drawingml/2006/main">
             <a:pPr algn="l">
+              <a:buNone/>
               <a:defRPr sz="825" b="1" i="0">
                 <a:solidFill>
                   <a:srgbClr val="F8F2E8">
@@ -7640,6 +7732,7 @@
           <a:lstStyle xmlns:a="http://schemas.openxmlformats.org/drawingml/2006/main"/>
           <a:p xmlns:a="http://schemas.openxmlformats.org/drawingml/2006/main">
             <a:pPr algn="r">
+              <a:buNone/>
               <a:defRPr sz="900" b="0" i="0">
                 <a:solidFill>
                   <a:srgbClr val="F8F2E8">
@@ -7761,6 +7854,7 @@
           <a:lstStyle xmlns:a="http://schemas.openxmlformats.org/drawingml/2006/main"/>
           <a:p xmlns:a="http://schemas.openxmlformats.org/drawingml/2006/main">
             <a:pPr algn="l">
+              <a:buNone/>
               <a:defRPr sz="975" b="1" i="0">
                 <a:solidFill>
                   <a:srgbClr val="C8A66A"/>
@@ -7804,6 +7898,7 @@
           <a:lstStyle xmlns:a="http://schemas.openxmlformats.org/drawingml/2006/main"/>
           <a:p xmlns:a="http://schemas.openxmlformats.org/drawingml/2006/main">
             <a:pPr algn="l">
+              <a:buNone/>
               <a:defRPr sz="3450" b="0" i="0">
                 <a:solidFill>
                   <a:srgbClr val="F8F2E8"/>
@@ -7847,6 +7942,7 @@
           <a:lstStyle xmlns:a="http://schemas.openxmlformats.org/drawingml/2006/main"/>
           <a:p xmlns:a="http://schemas.openxmlformats.org/drawingml/2006/main">
             <a:pPr algn="l">
+              <a:buNone/>
               <a:defRPr sz="1650" b="0" i="0">
                 <a:solidFill>
                   <a:srgbClr val="E9E0D0"/>
@@ -7929,6 +8025,7 @@
           <a:lstStyle xmlns:a="http://schemas.openxmlformats.org/drawingml/2006/main"/>
           <a:p xmlns:a="http://schemas.openxmlformats.org/drawingml/2006/main">
             <a:pPr algn="ctr">
+              <a:buNone/>
               <a:defRPr sz="2550" b="0" i="0">
                 <a:solidFill>
                   <a:srgbClr val="FFE4A9"/>
@@ -7972,6 +8069,7 @@
           <a:lstStyle xmlns:a="http://schemas.openxmlformats.org/drawingml/2006/main"/>
           <a:p xmlns:a="http://schemas.openxmlformats.org/drawingml/2006/main">
             <a:pPr algn="ctr">
+              <a:buNone/>
               <a:defRPr sz="1200" b="1" i="0">
                 <a:solidFill>
                   <a:srgbClr val="F3E8D8"/>
@@ -8054,6 +8152,7 @@
           <a:lstStyle xmlns:a="http://schemas.openxmlformats.org/drawingml/2006/main"/>
           <a:p xmlns:a="http://schemas.openxmlformats.org/drawingml/2006/main">
             <a:pPr algn="ctr">
+              <a:buNone/>
               <a:defRPr sz="1125" b="1" i="0">
                 <a:solidFill>
                   <a:srgbClr val="F8F2E8"/>
@@ -8165,6 +8264,7 @@
           <a:lstStyle xmlns:a="http://schemas.openxmlformats.org/drawingml/2006/main"/>
           <a:p xmlns:a="http://schemas.openxmlformats.org/drawingml/2006/main">
             <a:pPr algn="ctr">
+              <a:buNone/>
               <a:defRPr sz="1125" b="1" i="0">
                 <a:solidFill>
                   <a:srgbClr val="F8F2E8"/>
@@ -8276,6 +8376,7 @@
           <a:lstStyle xmlns:a="http://schemas.openxmlformats.org/drawingml/2006/main"/>
           <a:p xmlns:a="http://schemas.openxmlformats.org/drawingml/2006/main">
             <a:pPr algn="ctr">
+              <a:buNone/>
               <a:defRPr sz="1125" b="1" i="0">
                 <a:solidFill>
                   <a:srgbClr val="F8F2E8"/>
@@ -8387,6 +8488,7 @@
           <a:lstStyle xmlns:a="http://schemas.openxmlformats.org/drawingml/2006/main"/>
           <a:p xmlns:a="http://schemas.openxmlformats.org/drawingml/2006/main">
             <a:pPr algn="ctr">
+              <a:buNone/>
               <a:defRPr sz="1125" b="1" i="0">
                 <a:solidFill>
                   <a:srgbClr val="F8F2E8"/>
@@ -8498,6 +8600,7 @@
           <a:lstStyle xmlns:a="http://schemas.openxmlformats.org/drawingml/2006/main"/>
           <a:p xmlns:a="http://schemas.openxmlformats.org/drawingml/2006/main">
             <a:pPr algn="ctr">
+              <a:buNone/>
               <a:defRPr sz="1125" b="1" i="0">
                 <a:solidFill>
                   <a:srgbClr val="F8F2E8"/>
@@ -8609,6 +8712,7 @@
           <a:lstStyle xmlns:a="http://schemas.openxmlformats.org/drawingml/2006/main"/>
           <a:p xmlns:a="http://schemas.openxmlformats.org/drawingml/2006/main">
             <a:pPr algn="ctr">
+              <a:buNone/>
               <a:defRPr sz="1125" b="1" i="0">
                 <a:solidFill>
                   <a:srgbClr val="F8F2E8"/>
@@ -8710,6 +8814,7 @@
           <a:lstStyle xmlns:a="http://schemas.openxmlformats.org/drawingml/2006/main"/>
           <a:p xmlns:a="http://schemas.openxmlformats.org/drawingml/2006/main">
             <a:pPr algn="l">
+              <a:buNone/>
               <a:defRPr sz="825" b="1" i="0">
                 <a:solidFill>
                   <a:srgbClr val="F8F2E8">
@@ -8755,6 +8860,7 @@
           <a:lstStyle xmlns:a="http://schemas.openxmlformats.org/drawingml/2006/main"/>
           <a:p xmlns:a="http://schemas.openxmlformats.org/drawingml/2006/main">
             <a:pPr algn="r">
+              <a:buNone/>
               <a:defRPr sz="900" b="0" i="0">
                 <a:solidFill>
                   <a:srgbClr val="F8F2E8">
@@ -8803,7 +8909,7 @@
           <p:nvPr/>
         </p:nvPicPr>
         <p:blipFill>
-          <a:blip xmlns:r="http://schemas.openxmlformats.org/officeDocument/2006/relationships" xmlns:a="http://schemas.openxmlformats.org/drawingml/2006/main" r:embed="Rb3e0d121186e4752"/>
+          <a:blip xmlns:r="http://schemas.openxmlformats.org/officeDocument/2006/relationships" xmlns:a="http://schemas.openxmlformats.org/drawingml/2006/main" r:embed="R6ccd8f3daf2d4f37"/>
           <a:srcRect xmlns:a="http://schemas.openxmlformats.org/drawingml/2006/main" l="0" t="27" r="0" b="27"/>
           <a:stretch xmlns:a="http://schemas.openxmlformats.org/drawingml/2006/main">
             <a:fillRect l="0" t="0" r="0" b="0"/>
@@ -8901,6 +9007,7 @@
           <a:lstStyle xmlns:a="http://schemas.openxmlformats.org/drawingml/2006/main"/>
           <a:p xmlns:a="http://schemas.openxmlformats.org/drawingml/2006/main">
             <a:pPr algn="l">
+              <a:buNone/>
               <a:defRPr sz="975" b="1" i="0">
                 <a:solidFill>
                   <a:srgbClr val="C8A66A"/>
@@ -8944,6 +9051,7 @@
           <a:lstStyle xmlns:a="http://schemas.openxmlformats.org/drawingml/2006/main"/>
           <a:p xmlns:a="http://schemas.openxmlformats.org/drawingml/2006/main">
             <a:pPr algn="l">
+              <a:buNone/>
               <a:defRPr sz="3450" b="0" i="0">
                 <a:solidFill>
                   <a:srgbClr val="F8F2E8"/>
@@ -8987,6 +9095,7 @@
           <a:lstStyle xmlns:a="http://schemas.openxmlformats.org/drawingml/2006/main"/>
           <a:p xmlns:a="http://schemas.openxmlformats.org/drawingml/2006/main">
             <a:pPr algn="l">
+              <a:buNone/>
               <a:defRPr sz="1650" b="0" i="0">
                 <a:solidFill>
                   <a:srgbClr val="E9E0D0"/>
@@ -9018,8 +9127,8 @@
         </p:nvSpPr>
         <p:spPr>
           <a:xfrm xmlns:a="http://schemas.openxmlformats.org/drawingml/2006/main">
-            <a:off x="723900" y="3867150"/>
-            <a:ext cx="2095500" cy="1066800"/>
+            <a:off x="723900" y="3790950"/>
+            <a:ext cx="2095500" cy="1295400"/>
           </a:xfrm>
           <a:prstGeom xmlns:a="http://schemas.openxmlformats.org/drawingml/2006/main" prst="roundRect">
             <a:avLst>
@@ -9057,7 +9166,7 @@
         </p:nvSpPr>
         <p:spPr>
           <a:xfrm xmlns:a="http://schemas.openxmlformats.org/drawingml/2006/main">
-            <a:off x="952500" y="4076700"/>
+            <a:off x="952500" y="4000500"/>
             <a:ext cx="1638300" cy="323850"/>
           </a:xfrm>
           <a:prstGeom xmlns:a="http://schemas.openxmlformats.org/drawingml/2006/main" prst="rect">
@@ -9069,6 +9178,7 @@
           <a:lstStyle xmlns:a="http://schemas.openxmlformats.org/drawingml/2006/main"/>
           <a:p xmlns:a="http://schemas.openxmlformats.org/drawingml/2006/main">
             <a:pPr algn="l">
+              <a:buNone/>
               <a:defRPr sz="1575" b="1" i="0">
                 <a:solidFill>
                   <a:srgbClr val="F8F2E8"/>
@@ -9100,8 +9210,8 @@
         </p:nvSpPr>
         <p:spPr>
           <a:xfrm xmlns:a="http://schemas.openxmlformats.org/drawingml/2006/main">
-            <a:off x="952500" y="4495800"/>
-            <a:ext cx="1638300" cy="285750"/>
+            <a:off x="952500" y="4438650"/>
+            <a:ext cx="1638300" cy="514350"/>
           </a:xfrm>
           <a:prstGeom xmlns:a="http://schemas.openxmlformats.org/drawingml/2006/main" prst="rect">
             <a:avLst/>
@@ -9112,6 +9222,7 @@
           <a:lstStyle xmlns:a="http://schemas.openxmlformats.org/drawingml/2006/main"/>
           <a:p xmlns:a="http://schemas.openxmlformats.org/drawingml/2006/main">
             <a:pPr algn="l">
+              <a:buNone/>
               <a:defRPr sz="1200" b="0" i="0">
                 <a:solidFill>
                   <a:srgbClr val="DFD4C3"/>
@@ -9143,8 +9254,8 @@
         </p:nvSpPr>
         <p:spPr>
           <a:xfrm xmlns:a="http://schemas.openxmlformats.org/drawingml/2006/main">
-            <a:off x="3028950" y="3867150"/>
-            <a:ext cx="2095500" cy="1066800"/>
+            <a:off x="3028950" y="3790950"/>
+            <a:ext cx="2095500" cy="1295400"/>
           </a:xfrm>
           <a:prstGeom xmlns:a="http://schemas.openxmlformats.org/drawingml/2006/main" prst="roundRect">
             <a:avLst>
@@ -9182,7 +9293,7 @@
         </p:nvSpPr>
         <p:spPr>
           <a:xfrm xmlns:a="http://schemas.openxmlformats.org/drawingml/2006/main">
-            <a:off x="3257550" y="4076700"/>
+            <a:off x="3257550" y="4000500"/>
             <a:ext cx="1638300" cy="323850"/>
           </a:xfrm>
           <a:prstGeom xmlns:a="http://schemas.openxmlformats.org/drawingml/2006/main" prst="rect">
@@ -9194,6 +9305,7 @@
           <a:lstStyle xmlns:a="http://schemas.openxmlformats.org/drawingml/2006/main"/>
           <a:p xmlns:a="http://schemas.openxmlformats.org/drawingml/2006/main">
             <a:pPr algn="l">
+              <a:buNone/>
               <a:defRPr sz="1575" b="1" i="0">
                 <a:solidFill>
                   <a:srgbClr val="F8F2E8"/>
@@ -9225,8 +9337,8 @@
         </p:nvSpPr>
         <p:spPr>
           <a:xfrm xmlns:a="http://schemas.openxmlformats.org/drawingml/2006/main">
-            <a:off x="3257550" y="4495800"/>
-            <a:ext cx="1638300" cy="285750"/>
+            <a:off x="3257550" y="4438650"/>
+            <a:ext cx="1638300" cy="514350"/>
           </a:xfrm>
           <a:prstGeom xmlns:a="http://schemas.openxmlformats.org/drawingml/2006/main" prst="rect">
             <a:avLst/>
@@ -9237,6 +9349,7 @@
           <a:lstStyle xmlns:a="http://schemas.openxmlformats.org/drawingml/2006/main"/>
           <a:p xmlns:a="http://schemas.openxmlformats.org/drawingml/2006/main">
             <a:pPr algn="l">
+              <a:buNone/>
               <a:defRPr sz="1200" b="0" i="0">
                 <a:solidFill>
                   <a:srgbClr val="DFD4C3"/>
@@ -9268,8 +9381,8 @@
         </p:nvSpPr>
         <p:spPr>
           <a:xfrm xmlns:a="http://schemas.openxmlformats.org/drawingml/2006/main">
-            <a:off x="5334000" y="3867150"/>
-            <a:ext cx="2095500" cy="1066800"/>
+            <a:off x="5334000" y="3790950"/>
+            <a:ext cx="2095500" cy="1295400"/>
           </a:xfrm>
           <a:prstGeom xmlns:a="http://schemas.openxmlformats.org/drawingml/2006/main" prst="roundRect">
             <a:avLst>
@@ -9307,7 +9420,7 @@
         </p:nvSpPr>
         <p:spPr>
           <a:xfrm xmlns:a="http://schemas.openxmlformats.org/drawingml/2006/main">
-            <a:off x="5562600" y="4076700"/>
+            <a:off x="5562600" y="4000500"/>
             <a:ext cx="1638300" cy="323850"/>
           </a:xfrm>
           <a:prstGeom xmlns:a="http://schemas.openxmlformats.org/drawingml/2006/main" prst="rect">
@@ -9319,6 +9432,7 @@
           <a:lstStyle xmlns:a="http://schemas.openxmlformats.org/drawingml/2006/main"/>
           <a:p xmlns:a="http://schemas.openxmlformats.org/drawingml/2006/main">
             <a:pPr algn="l">
+              <a:buNone/>
               <a:defRPr sz="1575" b="1" i="0">
                 <a:solidFill>
                   <a:srgbClr val="F8F2E8"/>
@@ -9350,8 +9464,8 @@
         </p:nvSpPr>
         <p:spPr>
           <a:xfrm xmlns:a="http://schemas.openxmlformats.org/drawingml/2006/main">
-            <a:off x="5562600" y="4495800"/>
-            <a:ext cx="1638300" cy="285750"/>
+            <a:off x="5562600" y="4438650"/>
+            <a:ext cx="1638300" cy="514350"/>
           </a:xfrm>
           <a:prstGeom xmlns:a="http://schemas.openxmlformats.org/drawingml/2006/main" prst="rect">
             <a:avLst/>
@@ -9362,6 +9476,7 @@
           <a:lstStyle xmlns:a="http://schemas.openxmlformats.org/drawingml/2006/main"/>
           <a:p xmlns:a="http://schemas.openxmlformats.org/drawingml/2006/main">
             <a:pPr algn="l">
+              <a:buNone/>
               <a:defRPr sz="1200" b="0" i="0">
                 <a:solidFill>
                   <a:srgbClr val="DFD4C3"/>
@@ -9434,6 +9549,7 @@
           <a:lstStyle xmlns:a="http://schemas.openxmlformats.org/drawingml/2006/main"/>
           <a:p xmlns:a="http://schemas.openxmlformats.org/drawingml/2006/main">
             <a:pPr algn="l">
+              <a:buNone/>
               <a:defRPr sz="825" b="1" i="0">
                 <a:solidFill>
                   <a:srgbClr val="F8F2E8">
@@ -9479,6 +9595,7 @@
           <a:lstStyle xmlns:a="http://schemas.openxmlformats.org/drawingml/2006/main"/>
           <a:p xmlns:a="http://schemas.openxmlformats.org/drawingml/2006/main">
             <a:pPr algn="r">
+              <a:buNone/>
               <a:defRPr sz="900" b="0" i="0">
                 <a:solidFill>
                   <a:srgbClr val="F8F2E8">
@@ -9600,6 +9717,7 @@
           <a:lstStyle xmlns:a="http://schemas.openxmlformats.org/drawingml/2006/main"/>
           <a:p xmlns:a="http://schemas.openxmlformats.org/drawingml/2006/main">
             <a:pPr algn="l">
+              <a:buNone/>
               <a:defRPr sz="975" b="1" i="0">
                 <a:solidFill>
                   <a:srgbClr val="C8A66A"/>
@@ -9643,6 +9761,7 @@
           <a:lstStyle xmlns:a="http://schemas.openxmlformats.org/drawingml/2006/main"/>
           <a:p xmlns:a="http://schemas.openxmlformats.org/drawingml/2006/main">
             <a:pPr algn="l">
+              <a:buNone/>
               <a:defRPr sz="3450" b="0" i="0">
                 <a:solidFill>
                   <a:srgbClr val="F8F2E8"/>
@@ -9686,6 +9805,7 @@
           <a:lstStyle xmlns:a="http://schemas.openxmlformats.org/drawingml/2006/main"/>
           <a:p xmlns:a="http://schemas.openxmlformats.org/drawingml/2006/main">
             <a:pPr algn="l">
+              <a:buNone/>
               <a:defRPr sz="1650" b="0" i="0">
                 <a:solidFill>
                   <a:srgbClr val="E9E0D0"/>
@@ -9718,7 +9838,7 @@
         <p:spPr>
           <a:xfrm xmlns:a="http://schemas.openxmlformats.org/drawingml/2006/main">
             <a:off x="990600" y="3295650"/>
-            <a:ext cx="3048000" cy="1619250"/>
+            <a:ext cx="3048000" cy="1809750"/>
           </a:xfrm>
           <a:prstGeom xmlns:a="http://schemas.openxmlformats.org/drawingml/2006/main" prst="roundRect">
             <a:avLst>
@@ -9768,6 +9888,7 @@
           <a:lstStyle xmlns:a="http://schemas.openxmlformats.org/drawingml/2006/main"/>
           <a:p xmlns:a="http://schemas.openxmlformats.org/drawingml/2006/main">
             <a:pPr algn="l">
+              <a:buNone/>
               <a:defRPr sz="2250" b="0" i="0">
                 <a:solidFill>
                   <a:srgbClr val="D7C6A6"/>
@@ -9800,7 +9921,7 @@
         <p:spPr>
           <a:xfrm xmlns:a="http://schemas.openxmlformats.org/drawingml/2006/main">
             <a:off x="1295400" y="4095750"/>
-            <a:ext cx="2286000" cy="704850"/>
+            <a:ext cx="2286000" cy="876300"/>
           </a:xfrm>
           <a:prstGeom xmlns:a="http://schemas.openxmlformats.org/drawingml/2006/main" prst="rect">
             <a:avLst/>
@@ -9811,6 +9932,7 @@
           <a:lstStyle xmlns:a="http://schemas.openxmlformats.org/drawingml/2006/main"/>
           <a:p xmlns:a="http://schemas.openxmlformats.org/drawingml/2006/main">
             <a:pPr algn="l">
+              <a:buNone/>
               <a:defRPr sz="1200" b="0" i="0">
                 <a:solidFill>
                   <a:srgbClr val="D8CCBA"/>
@@ -9826,6 +9948,7 @@
           </a:p>
           <a:p xmlns:a="http://schemas.openxmlformats.org/drawingml/2006/main">
             <a:pPr algn="l">
+              <a:buNone/>
               <a:defRPr sz="1200" b="0" i="0">
                 <a:solidFill>
                   <a:srgbClr val="D8CCBA"/>
@@ -9841,6 +9964,7 @@
           </a:p>
           <a:p xmlns:a="http://schemas.openxmlformats.org/drawingml/2006/main">
             <a:pPr algn="l">
+              <a:buNone/>
               <a:defRPr sz="1200" b="0" i="0">
                 <a:solidFill>
                   <a:srgbClr val="D8CCBA"/>
@@ -9923,6 +10047,7 @@
           <a:lstStyle xmlns:a="http://schemas.openxmlformats.org/drawingml/2006/main"/>
           <a:p xmlns:a="http://schemas.openxmlformats.org/drawingml/2006/main">
             <a:pPr algn="l">
+              <a:buNone/>
               <a:defRPr sz="3000" b="0" i="0">
                 <a:solidFill>
                   <a:srgbClr val="FFE4A9"/>
@@ -9966,6 +10091,7 @@
           <a:lstStyle xmlns:a="http://schemas.openxmlformats.org/drawingml/2006/main"/>
           <a:p xmlns:a="http://schemas.openxmlformats.org/drawingml/2006/main">
             <a:pPr algn="l">
+              <a:buNone/>
               <a:defRPr sz="1350" b="0" i="0">
                 <a:solidFill>
                   <a:srgbClr val="F3E8D8"/>
@@ -9981,6 +10107,7 @@
           </a:p>
           <a:p xmlns:a="http://schemas.openxmlformats.org/drawingml/2006/main">
             <a:pPr algn="l">
+              <a:buNone/>
               <a:defRPr sz="1350" b="0" i="0">
                 <a:solidFill>
                   <a:srgbClr val="F3E8D8"/>
@@ -9996,6 +10123,7 @@
           </a:p>
           <a:p xmlns:a="http://schemas.openxmlformats.org/drawingml/2006/main">
             <a:pPr algn="l">
+              <a:buNone/>
               <a:defRPr sz="1350" b="0" i="0">
                 <a:solidFill>
                   <a:srgbClr val="F3E8D8"/>
@@ -10028,7 +10156,7 @@
         <p:spPr>
           <a:xfrm xmlns:a="http://schemas.openxmlformats.org/drawingml/2006/main">
             <a:off x="9067800" y="3295650"/>
-            <a:ext cx="2095500" cy="1619250"/>
+            <a:ext cx="2095500" cy="1809750"/>
           </a:xfrm>
           <a:prstGeom xmlns:a="http://schemas.openxmlformats.org/drawingml/2006/main" prst="roundRect">
             <a:avLst>
@@ -10078,6 +10206,7 @@
           <a:lstStyle xmlns:a="http://schemas.openxmlformats.org/drawingml/2006/main"/>
           <a:p xmlns:a="http://schemas.openxmlformats.org/drawingml/2006/main">
             <a:pPr algn="l">
+              <a:buNone/>
               <a:defRPr sz="2250" b="0" i="0">
                 <a:solidFill>
                   <a:srgbClr val="DCE8D0"/>
@@ -10110,7 +10239,7 @@
         <p:spPr>
           <a:xfrm xmlns:a="http://schemas.openxmlformats.org/drawingml/2006/main">
             <a:off x="9391650" y="4095750"/>
-            <a:ext cx="1352550" cy="723900"/>
+            <a:ext cx="1352550" cy="876300"/>
           </a:xfrm>
           <a:prstGeom xmlns:a="http://schemas.openxmlformats.org/drawingml/2006/main" prst="rect">
             <a:avLst/>
@@ -10121,6 +10250,7 @@
           <a:lstStyle xmlns:a="http://schemas.openxmlformats.org/drawingml/2006/main"/>
           <a:p xmlns:a="http://schemas.openxmlformats.org/drawingml/2006/main">
             <a:pPr algn="l">
+              <a:buNone/>
               <a:defRPr sz="1275" b="0" i="0">
                 <a:solidFill>
                   <a:srgbClr val="E6F0DC"/>
@@ -10193,6 +10323,7 @@
           <a:lstStyle xmlns:a="http://schemas.openxmlformats.org/drawingml/2006/main"/>
           <a:p xmlns:a="http://schemas.openxmlformats.org/drawingml/2006/main">
             <a:pPr algn="l">
+              <a:buNone/>
               <a:defRPr sz="825" b="1" i="0">
                 <a:solidFill>
                   <a:srgbClr val="F8F2E8">
@@ -10238,6 +10369,7 @@
           <a:lstStyle xmlns:a="http://schemas.openxmlformats.org/drawingml/2006/main"/>
           <a:p xmlns:a="http://schemas.openxmlformats.org/drawingml/2006/main">
             <a:pPr algn="r">
+              <a:buNone/>
               <a:defRPr sz="900" b="0" i="0">
                 <a:solidFill>
                   <a:srgbClr val="F8F2E8">
@@ -10359,6 +10491,7 @@
           <a:lstStyle xmlns:a="http://schemas.openxmlformats.org/drawingml/2006/main"/>
           <a:p xmlns:a="http://schemas.openxmlformats.org/drawingml/2006/main">
             <a:pPr algn="l">
+              <a:buNone/>
               <a:defRPr sz="975" b="1" i="0">
                 <a:solidFill>
                   <a:srgbClr val="C8A66A"/>
@@ -10402,6 +10535,7 @@
           <a:lstStyle xmlns:a="http://schemas.openxmlformats.org/drawingml/2006/main"/>
           <a:p xmlns:a="http://schemas.openxmlformats.org/drawingml/2006/main">
             <a:pPr algn="l">
+              <a:buNone/>
               <a:defRPr sz="3450" b="0" i="0">
                 <a:solidFill>
                   <a:srgbClr val="F8F2E8"/>
@@ -10445,6 +10579,7 @@
           <a:lstStyle xmlns:a="http://schemas.openxmlformats.org/drawingml/2006/main"/>
           <a:p xmlns:a="http://schemas.openxmlformats.org/drawingml/2006/main">
             <a:pPr algn="l">
+              <a:buNone/>
               <a:defRPr sz="1650" b="0" i="0">
                 <a:solidFill>
                   <a:srgbClr val="E9E0D0"/>
@@ -10527,6 +10662,7 @@
           <a:lstStyle xmlns:a="http://schemas.openxmlformats.org/drawingml/2006/main"/>
           <a:p xmlns:a="http://schemas.openxmlformats.org/drawingml/2006/main">
             <a:pPr algn="ctr">
+              <a:buNone/>
               <a:defRPr sz="1275" b="1" i="0">
                 <a:solidFill>
                   <a:srgbClr val="F8F2E8"/>
@@ -10609,6 +10745,7 @@
           <a:lstStyle xmlns:a="http://schemas.openxmlformats.org/drawingml/2006/main"/>
           <a:p xmlns:a="http://schemas.openxmlformats.org/drawingml/2006/main">
             <a:pPr algn="ctr">
+              <a:buNone/>
               <a:defRPr sz="1275" b="1" i="0">
                 <a:solidFill>
                   <a:srgbClr val="F8F2E8"/>
@@ -10691,6 +10828,7 @@
           <a:lstStyle xmlns:a="http://schemas.openxmlformats.org/drawingml/2006/main"/>
           <a:p xmlns:a="http://schemas.openxmlformats.org/drawingml/2006/main">
             <a:pPr algn="ctr">
+              <a:buNone/>
               <a:defRPr sz="1275" b="1" i="0">
                 <a:solidFill>
                   <a:srgbClr val="FFE4A9"/>
@@ -10773,6 +10911,7 @@
           <a:lstStyle xmlns:a="http://schemas.openxmlformats.org/drawingml/2006/main"/>
           <a:p xmlns:a="http://schemas.openxmlformats.org/drawingml/2006/main">
             <a:pPr algn="ctr">
+              <a:buNone/>
               <a:defRPr sz="1275" b="1" i="0">
                 <a:solidFill>
                   <a:srgbClr val="F8F2E8"/>
@@ -10855,6 +10994,7 @@
           <a:lstStyle xmlns:a="http://schemas.openxmlformats.org/drawingml/2006/main"/>
           <a:p xmlns:a="http://schemas.openxmlformats.org/drawingml/2006/main">
             <a:pPr algn="ctr">
+              <a:buNone/>
               <a:defRPr sz="1275" b="1" i="0">
                 <a:solidFill>
                   <a:srgbClr val="F8F2E8"/>
@@ -11002,8 +11142,8 @@
         </p:nvSpPr>
         <p:spPr>
           <a:xfrm xmlns:a="http://schemas.openxmlformats.org/drawingml/2006/main">
-            <a:off x="8858250" y="3371850"/>
-            <a:ext cx="2114550" cy="1238250"/>
+            <a:off x="9525000" y="3219450"/>
+            <a:ext cx="2190750" cy="1638300"/>
           </a:xfrm>
           <a:prstGeom xmlns:a="http://schemas.openxmlformats.org/drawingml/2006/main" prst="roundRect">
             <a:avLst>
@@ -11041,8 +11181,8 @@
         </p:nvSpPr>
         <p:spPr>
           <a:xfrm xmlns:a="http://schemas.openxmlformats.org/drawingml/2006/main">
-            <a:off x="9105900" y="3638550"/>
-            <a:ext cx="1619250" cy="266700"/>
+            <a:off x="9753600" y="3486150"/>
+            <a:ext cx="1714500" cy="419100"/>
           </a:xfrm>
           <a:prstGeom xmlns:a="http://schemas.openxmlformats.org/drawingml/2006/main" prst="rect">
             <a:avLst/>
@@ -11053,6 +11193,7 @@
           <a:lstStyle xmlns:a="http://schemas.openxmlformats.org/drawingml/2006/main"/>
           <a:p xmlns:a="http://schemas.openxmlformats.org/drawingml/2006/main">
             <a:pPr algn="l">
+              <a:buNone/>
               <a:defRPr sz="1350" b="1" i="0">
                 <a:solidFill>
                   <a:srgbClr val="F8F2E8"/>
@@ -11084,8 +11225,8 @@
         </p:nvSpPr>
         <p:spPr>
           <a:xfrm xmlns:a="http://schemas.openxmlformats.org/drawingml/2006/main">
-            <a:off x="9124950" y="4038600"/>
-            <a:ext cx="1619250" cy="552450"/>
+            <a:off x="9772650" y="4000500"/>
+            <a:ext cx="1619250" cy="742950"/>
           </a:xfrm>
           <a:prstGeom xmlns:a="http://schemas.openxmlformats.org/drawingml/2006/main" prst="rect">
             <a:avLst/>
@@ -11096,6 +11237,7 @@
           <a:lstStyle xmlns:a="http://schemas.openxmlformats.org/drawingml/2006/main"/>
           <a:p xmlns:a="http://schemas.openxmlformats.org/drawingml/2006/main">
             <a:pPr algn="l">
+              <a:buNone/>
               <a:defRPr sz="1125" b="0" i="0">
                 <a:solidFill>
                   <a:srgbClr val="D8CCBA"/>
@@ -11111,6 +11253,7 @@
           </a:p>
           <a:p xmlns:a="http://schemas.openxmlformats.org/drawingml/2006/main">
             <a:pPr algn="l">
+              <a:buNone/>
               <a:defRPr sz="1125" b="0" i="0">
                 <a:solidFill>
                   <a:srgbClr val="D8CCBA"/>
@@ -11126,6 +11269,7 @@
           </a:p>
           <a:p xmlns:a="http://schemas.openxmlformats.org/drawingml/2006/main">
             <a:pPr algn="l">
+              <a:buNone/>
               <a:defRPr sz="1125" b="0" i="0">
                 <a:solidFill>
                   <a:srgbClr val="D8CCBA"/>
@@ -11141,6 +11285,7 @@
           </a:p>
           <a:p xmlns:a="http://schemas.openxmlformats.org/drawingml/2006/main">
             <a:pPr algn="l">
+              <a:buNone/>
               <a:defRPr sz="1125" b="0" i="0">
                 <a:solidFill>
                   <a:srgbClr val="D8CCBA"/>
@@ -11213,6 +11358,7 @@
           <a:lstStyle xmlns:a="http://schemas.openxmlformats.org/drawingml/2006/main"/>
           <a:p xmlns:a="http://schemas.openxmlformats.org/drawingml/2006/main">
             <a:pPr algn="l">
+              <a:buNone/>
               <a:defRPr sz="825" b="1" i="0">
                 <a:solidFill>
                   <a:srgbClr val="F8F2E8">
@@ -11258,6 +11404,7 @@
           <a:lstStyle xmlns:a="http://schemas.openxmlformats.org/drawingml/2006/main"/>
           <a:p xmlns:a="http://schemas.openxmlformats.org/drawingml/2006/main">
             <a:pPr algn="r">
+              <a:buNone/>
               <a:defRPr sz="900" b="0" i="0">
                 <a:solidFill>
                   <a:srgbClr val="F8F2E8">

</xml_diff>